<commit_message>
Apply slide-taste review to sg-life-test deck (6.9 -> 7.4)
Bigger cover title, MRT East-West line as the deck idea (cover, day timeline,
next-stop tips), note moved to footer. Before/after sheets in review/.

Co-Authored-By: Claude Opus 5.5 <noreply@anthropic.com>
Claude-Session: https://claude.ai/code/session_01PHKBCXsZEkgPMV9CPhwUsE
</commit_message>
<xml_diff>
--- a/decks/sg-life-test_20261016/sg-life-test.pptx
+++ b/decks/sg-life-test_20261016/sg-life-test.pptx
@@ -689,10 +689,10 @@
         </p:nvGrpSpPr>
         <p:grpSpPr>
           <a:xfrm>
-            <a:off x="666750" y="1968500"/>
-            <a:ext cx="3915156" cy="2438400"/>
-            <a:chOff x="666750" y="1968500"/>
-            <a:chExt cx="3915156" cy="2438400"/>
+            <a:off x="666750" y="1581150"/>
+            <a:ext cx="5207508" cy="3181350"/>
+            <a:chOff x="666750" y="1581150"/>
+            <a:chExt cx="5207508" cy="3181350"/>
           </a:xfrm>
         </p:grpSpPr>
         <p:sp>
@@ -703,8 +703,8 @@
           </p:nvSpPr>
           <p:spPr>
             <a:xfrm>
-              <a:off x="666750" y="1968500"/>
-              <a:ext cx="2945892" cy="1390650"/>
+              <a:off x="666750" y="1581150"/>
+              <a:ext cx="3915156" cy="1847850"/>
             </a:xfrm>
             <a:prstGeom prst="rect">
               <a:avLst/>
@@ -722,7 +722,7 @@
             <a:p>
               <a:pPr algn="l"/>
               <a:r>
-                <a:rPr lang="zh-TW" sz="7200" b="1" dirty="0">
+                <a:rPr lang="zh-TW" sz="9600" b="1" dirty="0">
                   <a:solidFill>
                     <a:srgbClr val="121316"/>
                   </a:solidFill>
@@ -743,8 +743,8 @@
           </p:nvSpPr>
           <p:spPr>
             <a:xfrm>
-              <a:off x="666750" y="3016250"/>
-              <a:ext cx="3915156" cy="1390650"/>
+              <a:off x="666750" y="2914650"/>
+              <a:ext cx="5207508" cy="1847850"/>
             </a:xfrm>
             <a:prstGeom prst="rect">
               <a:avLst/>
@@ -762,7 +762,7 @@
             <a:p>
               <a:pPr algn="l"/>
               <a:r>
-                <a:rPr lang="zh-TW" sz="7200" b="1" dirty="0">
+                <a:rPr lang="zh-TW" sz="9600" b="1" dirty="0">
                   <a:solidFill>
                     <a:srgbClr val="121316"/>
                   </a:solidFill>
@@ -784,10 +784,10 @@
         </p:nvGrpSpPr>
         <p:grpSpPr>
           <a:xfrm>
-            <a:off x="675894" y="4464050"/>
-            <a:ext cx="4744974" cy="381381"/>
-            <a:chOff x="675894" y="4464050"/>
-            <a:chExt cx="4744974" cy="381381"/>
+            <a:off x="675894" y="4597400"/>
+            <a:ext cx="2907411" cy="381381"/>
+            <a:chOff x="675894" y="4597400"/>
+            <a:chExt cx="2907411" cy="381381"/>
           </a:xfrm>
         </p:grpSpPr>
         <p:sp>
@@ -798,8 +798,8 @@
           </p:nvSpPr>
           <p:spPr>
             <a:xfrm>
-              <a:off x="675894" y="4464050"/>
-              <a:ext cx="4744974" cy="381381"/>
+              <a:off x="675894" y="4597400"/>
+              <a:ext cx="2907411" cy="381381"/>
             </a:xfrm>
             <a:prstGeom prst="rect">
               <a:avLst/>
@@ -825,7 +825,7 @@
                   <a:ea typeface="+mn-ea"/>
                   <a:cs typeface="+mn-cs"/>
                 </a:rPr>
-                <a:t>一位區塊鏈碩士生的課堂、生活與小發現</a:t>
+                <a:t>一位區塊鏈碩士生的一年</a:t>
               </a:r>
             </a:p>
           </p:txBody>
@@ -833,7 +833,280 @@
       </p:grpSp>
       <p:grpSp>
         <p:nvGrpSpPr>
-          <p:cNvPr id="12" name="field"/>
+          <p:cNvPr id="18" name="route"/>
+          <p:cNvGrpSpPr/>
+          <p:nvPr/>
+        </p:nvGrpSpPr>
+        <p:grpSpPr>
+          <a:xfrm>
+            <a:off x="678942" y="5391150"/>
+            <a:ext cx="7322058" cy="670433"/>
+            <a:chOff x="678942" y="5391150"/>
+            <a:chExt cx="7322058" cy="670433"/>
+          </a:xfrm>
+        </p:grpSpPr>
+        <p:sp>
+          <p:nvSpPr>
+            <p:cNvPr id="9" name="Line 9"/>
+            <p:cNvSpPr/>
+            <p:nvPr/>
+          </p:nvSpPr>
+          <p:spPr>
+            <a:xfrm>
+              <a:off x="819150" y="5524500"/>
+              <a:ext cx="7181850" cy="9525"/>
+            </a:xfrm>
+            <a:custGeom>
+              <a:avLst/>
+              <a:gdLst/>
+              <a:ahLst/>
+              <a:cxnLst/>
+              <a:rect l="l" t="t" r="r" b="b"/>
+              <a:pathLst>
+                <a:path w="7181850" h="9525">
+                  <a:moveTo>
+                    <a:pt x="0" y="0"/>
+                  </a:moveTo>
+                  <a:lnTo>
+                    <a:pt x="7181850" y="0"/>
+                  </a:lnTo>
+                </a:path>
+              </a:pathLst>
+            </a:custGeom>
+            <a:noFill/>
+            <a:ln w="114300" cap="rnd">
+              <a:solidFill>
+                <a:srgbClr val="009645"/>
+              </a:solidFill>
+            </a:ln>
+          </p:spPr>
+        </p:sp>
+        <p:grpSp>
+          <p:nvGrpSpPr>
+            <p:cNvPr id="13" name="Group 13"/>
+            <p:cNvGrpSpPr/>
+            <p:nvPr/>
+          </p:nvGrpSpPr>
+          <p:grpSpPr>
+            <a:xfrm>
+              <a:off x="685800" y="5391150"/>
+              <a:ext cx="4914900" cy="266700"/>
+              <a:chOff x="685800" y="5391150"/>
+              <a:chExt cx="4914900" cy="266700"/>
+            </a:xfrm>
+          </p:grpSpPr>
+          <p:sp>
+            <p:nvSpPr>
+              <p:cNvPr id="10" name="Ellipse 10"/>
+              <p:cNvSpPr/>
+              <p:nvPr/>
+            </p:nvSpPr>
+            <p:spPr>
+              <a:xfrm>
+                <a:off x="685800" y="5391150"/>
+                <a:ext cx="266700" cy="266700"/>
+              </a:xfrm>
+              <a:prstGeom prst="ellipse">
+                <a:avLst/>
+              </a:prstGeom>
+              <a:solidFill>
+                <a:srgbClr val="FFFFFF"/>
+              </a:solidFill>
+              <a:ln w="57150">
+                <a:solidFill>
+                  <a:srgbClr val="009645"/>
+                </a:solidFill>
+              </a:ln>
+            </p:spPr>
+          </p:sp>
+          <p:sp>
+            <p:nvSpPr>
+              <p:cNvPr id="11" name="Ellipse 11"/>
+              <p:cNvSpPr/>
+              <p:nvPr/>
+            </p:nvSpPr>
+            <p:spPr>
+              <a:xfrm>
+                <a:off x="3009900" y="5391150"/>
+                <a:ext cx="266700" cy="266700"/>
+              </a:xfrm>
+              <a:prstGeom prst="ellipse">
+                <a:avLst/>
+              </a:prstGeom>
+              <a:solidFill>
+                <a:srgbClr val="FFFFFF"/>
+              </a:solidFill>
+              <a:ln w="57150">
+                <a:solidFill>
+                  <a:srgbClr val="009645"/>
+                </a:solidFill>
+              </a:ln>
+            </p:spPr>
+          </p:sp>
+          <p:sp>
+            <p:nvSpPr>
+              <p:cNvPr id="12" name="Ellipse 12"/>
+              <p:cNvSpPr/>
+              <p:nvPr/>
+            </p:nvSpPr>
+            <p:spPr>
+              <a:xfrm>
+                <a:off x="5334000" y="5391150"/>
+                <a:ext cx="266700" cy="266700"/>
+              </a:xfrm>
+              <a:prstGeom prst="ellipse">
+                <a:avLst/>
+              </a:prstGeom>
+              <a:solidFill>
+                <a:srgbClr val="FFFFFF"/>
+              </a:solidFill>
+              <a:ln w="57150">
+                <a:solidFill>
+                  <a:srgbClr val="009645"/>
+                </a:solidFill>
+              </a:ln>
+            </p:spPr>
+          </p:sp>
+        </p:grpSp>
+        <p:grpSp>
+          <p:nvGrpSpPr>
+            <p:cNvPr id="17" name="Group 17"/>
+            <p:cNvGrpSpPr/>
+            <p:nvPr/>
+          </p:nvGrpSpPr>
+          <p:grpSpPr>
+            <a:xfrm>
+              <a:off x="678942" y="5797550"/>
+              <a:ext cx="5207127" cy="264033"/>
+              <a:chOff x="678942" y="5797550"/>
+              <a:chExt cx="5207127" cy="264033"/>
+            </a:xfrm>
+          </p:grpSpPr>
+          <p:sp>
+            <p:nvSpPr>
+              <p:cNvPr id="14" name="TextBox 14"/>
+              <p:cNvSpPr txBox="1"/>
+              <p:nvPr/>
+            </p:nvSpPr>
+            <p:spPr>
+              <a:xfrm>
+                <a:off x="678942" y="5797550"/>
+                <a:ext cx="377190" cy="264033"/>
+              </a:xfrm>
+              <a:prstGeom prst="rect">
+                <a:avLst/>
+              </a:prstGeom>
+              <a:noFill/>
+              <a:ln>
+                <a:noFill/>
+              </a:ln>
+            </p:spPr>
+            <p:txBody>
+              <a:bodyPr wrap="none" lIns="0" tIns="0" rIns="0" bIns="0" anchor="t" anchorCtr="0">
+                <a:spAutoFit/>
+              </a:bodyPr>
+              <a:lstStyle/>
+              <a:p>
+                <a:pPr algn="l"/>
+                <a:r>
+                  <a:rPr lang="zh-TW" sz="1350" dirty="0">
+                    <a:solidFill>
+                      <a:srgbClr val="121316"/>
+                    </a:solidFill>
+                    <a:latin typeface="+mn-lt"/>
+                    <a:ea typeface="+mn-ea"/>
+                    <a:cs typeface="+mn-cs"/>
+                  </a:rPr>
+                  <a:t>課堂</a:t>
+                </a:r>
+              </a:p>
+            </p:txBody>
+          </p:sp>
+          <p:sp>
+            <p:nvSpPr>
+              <p:cNvPr id="15" name="TextBox 15"/>
+              <p:cNvSpPr txBox="1"/>
+              <p:nvPr/>
+            </p:nvSpPr>
+            <p:spPr>
+              <a:xfrm>
+                <a:off x="3003042" y="5797550"/>
+                <a:ext cx="377190" cy="264033"/>
+              </a:xfrm>
+              <a:prstGeom prst="rect">
+                <a:avLst/>
+              </a:prstGeom>
+              <a:noFill/>
+              <a:ln>
+                <a:noFill/>
+              </a:ln>
+            </p:spPr>
+            <p:txBody>
+              <a:bodyPr wrap="none" lIns="0" tIns="0" rIns="0" bIns="0" anchor="t" anchorCtr="0">
+                <a:spAutoFit/>
+              </a:bodyPr>
+              <a:lstStyle/>
+              <a:p>
+                <a:pPr algn="l"/>
+                <a:r>
+                  <a:rPr lang="zh-TW" sz="1350" dirty="0">
+                    <a:solidFill>
+                      <a:srgbClr val="121316"/>
+                    </a:solidFill>
+                    <a:latin typeface="+mn-lt"/>
+                    <a:ea typeface="+mn-ea"/>
+                    <a:cs typeface="+mn-cs"/>
+                  </a:rPr>
+                  <a:t>生活</a:t>
+                </a:r>
+              </a:p>
+            </p:txBody>
+          </p:sp>
+          <p:sp>
+            <p:nvSpPr>
+              <p:cNvPr id="16" name="TextBox 16"/>
+              <p:cNvSpPr txBox="1"/>
+              <p:nvPr/>
+            </p:nvSpPr>
+            <p:spPr>
+              <a:xfrm>
+                <a:off x="5327142" y="5797550"/>
+                <a:ext cx="558927" cy="264033"/>
+              </a:xfrm>
+              <a:prstGeom prst="rect">
+                <a:avLst/>
+              </a:prstGeom>
+              <a:noFill/>
+              <a:ln>
+                <a:noFill/>
+              </a:ln>
+            </p:spPr>
+            <p:txBody>
+              <a:bodyPr wrap="none" lIns="0" tIns="0" rIns="0" bIns="0" anchor="t" anchorCtr="0">
+                <a:spAutoFit/>
+              </a:bodyPr>
+              <a:lstStyle/>
+              <a:p>
+                <a:pPr algn="l"/>
+                <a:r>
+                  <a:rPr lang="zh-TW" sz="1350" dirty="0">
+                    <a:solidFill>
+                      <a:srgbClr val="121316"/>
+                    </a:solidFill>
+                    <a:latin typeface="+mn-lt"/>
+                    <a:ea typeface="+mn-ea"/>
+                    <a:cs typeface="+mn-cs"/>
+                  </a:rPr>
+                  <a:t>小發現</a:t>
+                </a:r>
+              </a:p>
+            </p:txBody>
+          </p:sp>
+        </p:grpSp>
+      </p:grpSp>
+      <p:grpSp>
+        <p:nvGrpSpPr>
+          <p:cNvPr id="22" name="field"/>
           <p:cNvGrpSpPr/>
           <p:nvPr/>
         </p:nvGrpSpPr>
@@ -847,7 +1120,7 @@
         </p:grpSpPr>
         <p:sp>
           <p:nvSpPr>
-            <p:cNvPr id="9" name="Rectangle 9"/>
+            <p:cNvPr id="19" name="Rectangle 19"/>
             <p:cNvSpPr/>
             <p:nvPr/>
           </p:nvSpPr>
@@ -869,7 +1142,7 @@
         </p:sp>
         <p:sp>
           <p:nvSpPr>
-            <p:cNvPr id="10" name="TextBox 10"/>
+            <p:cNvPr id="20" name="TextBox 20"/>
             <p:cNvSpPr txBox="1"/>
             <p:nvPr/>
           </p:nvSpPr>
@@ -911,14 +1184,14 @@
         </p:sp>
         <p:sp>
           <p:nvSpPr>
-            <p:cNvPr id="11" name="TextBox 11"/>
+            <p:cNvPr id="21" name="TextBox 21"/>
             <p:cNvSpPr txBox="1"/>
             <p:nvPr/>
           </p:nvSpPr>
           <p:spPr>
             <a:xfrm>
-              <a:off x="8362950" y="4978400"/>
-              <a:ext cx="3664793" cy="1733550"/>
+              <a:off x="8362950" y="5499100"/>
+              <a:ext cx="1972336" cy="933450"/>
             </a:xfrm>
             <a:prstGeom prst="rect">
               <a:avLst/>
@@ -936,7 +1209,7 @@
             <a:p>
               <a:pPr algn="l"/>
               <a:r>
-                <a:rPr lang="en-US" sz="9000" b="1" dirty="0">
+                <a:rPr lang="en-US" sz="4800" b="1" dirty="0">
                   <a:solidFill>
                     <a:srgbClr val="FFFFFF"/>
                   </a:solidFill>
@@ -952,27 +1225,27 @@
       </p:grpSp>
       <p:grpSp>
         <p:nvGrpSpPr>
-          <p:cNvPr id="14" name="draft-note"/>
+          <p:cNvPr id="24" name="draft-note"/>
           <p:cNvGrpSpPr/>
           <p:nvPr/>
         </p:nvGrpSpPr>
         <p:grpSpPr>
           <a:xfrm>
-            <a:off x="679704" y="6286500"/>
+            <a:off x="679704" y="6324600"/>
             <a:ext cx="3081528" cy="234696"/>
-            <a:chOff x="679704" y="6286500"/>
+            <a:chOff x="679704" y="6324600"/>
             <a:chExt cx="3081528" cy="234696"/>
           </a:xfrm>
         </p:grpSpPr>
         <p:sp>
           <p:nvSpPr>
-            <p:cNvPr id="13" name="TextBox 13"/>
+            <p:cNvPr id="23" name="TextBox 23"/>
             <p:cNvSpPr txBox="1"/>
             <p:nvPr/>
           </p:nvSpPr>
           <p:spPr>
             <a:xfrm>
-              <a:off x="679704" y="6286500"/>
+              <a:off x="679704" y="6324600"/>
               <a:ext cx="3081528" cy="234696"/>
             </a:xfrm>
             <a:prstGeom prst="rect">
@@ -1144,10 +1417,10 @@
         </p:nvGrpSpPr>
         <p:grpSpPr>
           <a:xfrm>
-            <a:off x="666750" y="2622550"/>
-            <a:ext cx="2514600" cy="2261870"/>
-            <a:chOff x="666750" y="2622550"/>
-            <a:chExt cx="2514600" cy="2261870"/>
+            <a:off x="666750" y="2641600"/>
+            <a:ext cx="2800350" cy="2475357"/>
+            <a:chOff x="666750" y="2641600"/>
+            <a:chExt cx="2800350" cy="2475357"/>
           </a:xfrm>
         </p:grpSpPr>
         <p:sp>
@@ -1158,8 +1431,8 @@
           </p:nvSpPr>
           <p:spPr>
             <a:xfrm>
-              <a:off x="666750" y="2622550"/>
-              <a:ext cx="1484290" cy="819150"/>
+              <a:off x="666750" y="2641600"/>
+              <a:ext cx="1690889" cy="933450"/>
             </a:xfrm>
             <a:prstGeom prst="rect">
               <a:avLst/>
@@ -1177,7 +1450,7 @@
             <a:p>
               <a:pPr algn="l"/>
               <a:r>
-                <a:rPr lang="zh-TW" sz="4200" b="1" dirty="0">
+                <a:rPr lang="zh-TW" sz="4800" b="1" dirty="0">
                   <a:solidFill>
                     <a:srgbClr val="121316"/>
                   </a:solidFill>
@@ -1198,8 +1471,8 @@
           </p:nvSpPr>
           <p:spPr>
             <a:xfrm>
-              <a:off x="685800" y="3486150"/>
-              <a:ext cx="2495550" cy="9525"/>
+              <a:off x="857250" y="3619500"/>
+              <a:ext cx="2609850" cy="9525"/>
             </a:xfrm>
             <a:custGeom>
               <a:avLst/>
@@ -1208,20 +1481,20 @@
               <a:cxnLst/>
               <a:rect l="l" t="t" r="r" b="b"/>
               <a:pathLst>
-                <a:path w="2495550" h="9525">
+                <a:path w="2609850" h="9525">
                   <a:moveTo>
                     <a:pt x="0" y="0"/>
                   </a:moveTo>
                   <a:lnTo>
-                    <a:pt x="2495550" y="0"/>
+                    <a:pt x="2609850" y="0"/>
                   </a:lnTo>
                 </a:path>
               </a:pathLst>
             </a:custGeom>
             <a:noFill/>
-            <a:ln w="19050">
+            <a:ln w="114300" cap="rnd">
               <a:solidFill>
-                <a:srgbClr val="121316"/>
+                <a:srgbClr val="009645"/>
               </a:solidFill>
             </a:ln>
           </p:spPr>
@@ -1234,17 +1507,19 @@
           </p:nvSpPr>
           <p:spPr>
             <a:xfrm>
-              <a:off x="685800" y="3400425"/>
-              <a:ext cx="171450" cy="171450"/>
+              <a:off x="704850" y="3467100"/>
+              <a:ext cx="304800" cy="304800"/>
             </a:xfrm>
             <a:prstGeom prst="ellipse">
               <a:avLst/>
             </a:prstGeom>
             <a:solidFill>
-              <a:srgbClr val="121316"/>
+              <a:srgbClr val="FFFFFF"/>
             </a:solidFill>
-            <a:ln>
-              <a:noFill/>
+            <a:ln w="57150">
+              <a:solidFill>
+                <a:srgbClr val="009645"/>
+              </a:solidFill>
             </a:ln>
           </p:spPr>
         </p:sp>
@@ -1256,8 +1531,8 @@
           </p:nvSpPr>
           <p:spPr>
             <a:xfrm>
-              <a:off x="675132" y="3841750"/>
-              <a:ext cx="586740" cy="410718"/>
+              <a:off x="673608" y="4013200"/>
+              <a:ext cx="670560" cy="469392"/>
             </a:xfrm>
             <a:prstGeom prst="rect">
               <a:avLst/>
@@ -1275,7 +1550,7 @@
             <a:p>
               <a:pPr algn="l"/>
               <a:r>
-                <a:rPr lang="zh-TW" sz="2100" b="1" dirty="0">
+                <a:rPr lang="zh-TW" sz="2400" b="1" dirty="0">
                   <a:solidFill>
                     <a:srgbClr val="121316"/>
                   </a:solidFill>
@@ -1296,8 +1571,8 @@
           </p:nvSpPr>
           <p:spPr>
             <a:xfrm>
-              <a:off x="678180" y="4286250"/>
-              <a:ext cx="1539240" cy="598170"/>
+              <a:off x="677418" y="4470400"/>
+              <a:ext cx="1693164" cy="646557"/>
             </a:xfrm>
             <a:prstGeom prst="rect">
               <a:avLst/>
@@ -1315,11 +1590,11 @@
             <a:p>
               <a:pPr algn="l">
                 <a:lnSpc>
-                  <a:spcPts val="2400"/>
+                  <a:spcPts val="2550"/>
                 </a:lnSpc>
               </a:pPr>
               <a:r>
-                <a:rPr lang="zh-TW" sz="1500" dirty="0">
+                <a:rPr lang="zh-TW" sz="1650" dirty="0">
                   <a:solidFill>
                     <a:srgbClr val="6B6D73"/>
                   </a:solidFill>
@@ -1330,7 +1605,7 @@
                 <a:t>課堂與實驗課，</a:t>
               </a:r>
               <a:br>
-                <a:rPr lang="zh-TW" sz="1500" dirty="0">
+                <a:rPr lang="zh-TW" sz="1650" dirty="0">
                   <a:solidFill>
                     <a:srgbClr val="6B6D73"/>
                   </a:solidFill>
@@ -1340,7 +1615,7 @@
                 </a:rPr>
               </a:br>
               <a:r>
-                <a:rPr lang="zh-TW" sz="1500" dirty="0">
+                <a:rPr lang="zh-TW" sz="1650" dirty="0">
                   <a:solidFill>
                     <a:srgbClr val="6B6D73"/>
                   </a:solidFill>
@@ -1362,10 +1637,10 @@
         </p:nvGrpSpPr>
         <p:grpSpPr>
           <a:xfrm>
-            <a:off x="3448050" y="2622550"/>
-            <a:ext cx="2514600" cy="2261870"/>
-            <a:chOff x="3448050" y="2622550"/>
-            <a:chExt cx="2514600" cy="2261870"/>
+            <a:off x="3448050" y="2641600"/>
+            <a:ext cx="2800350" cy="2475357"/>
+            <a:chOff x="3448050" y="2641600"/>
+            <a:chExt cx="2800350" cy="2475357"/>
           </a:xfrm>
         </p:grpSpPr>
         <p:sp>
@@ -1376,8 +1651,8 @@
           </p:nvSpPr>
           <p:spPr>
             <a:xfrm>
-              <a:off x="3448050" y="2622550"/>
-              <a:ext cx="1484290" cy="819150"/>
+              <a:off x="3448050" y="2641600"/>
+              <a:ext cx="1690889" cy="933450"/>
             </a:xfrm>
             <a:prstGeom prst="rect">
               <a:avLst/>
@@ -1395,7 +1670,7 @@
             <a:p>
               <a:pPr algn="l"/>
               <a:r>
-                <a:rPr lang="zh-TW" sz="4200" b="1" dirty="0">
+                <a:rPr lang="zh-TW" sz="4800" b="1" dirty="0">
                   <a:solidFill>
                     <a:srgbClr val="2445FF"/>
                   </a:solidFill>
@@ -1416,8 +1691,8 @@
           </p:nvSpPr>
           <p:spPr>
             <a:xfrm>
-              <a:off x="3467100" y="3486150"/>
-              <a:ext cx="2495550" cy="9525"/>
+              <a:off x="3638550" y="3619500"/>
+              <a:ext cx="2609850" cy="9525"/>
             </a:xfrm>
             <a:custGeom>
               <a:avLst/>
@@ -1426,20 +1701,20 @@
               <a:cxnLst/>
               <a:rect l="l" t="t" r="r" b="b"/>
               <a:pathLst>
-                <a:path w="2495550" h="9525">
+                <a:path w="2609850" h="9525">
                   <a:moveTo>
                     <a:pt x="0" y="0"/>
                   </a:moveTo>
                   <a:lnTo>
-                    <a:pt x="2495550" y="0"/>
+                    <a:pt x="2609850" y="0"/>
                   </a:lnTo>
                 </a:path>
               </a:pathLst>
             </a:custGeom>
             <a:noFill/>
-            <a:ln w="19050">
+            <a:ln w="114300">
               <a:solidFill>
-                <a:srgbClr val="2445FF"/>
+                <a:srgbClr val="009645"/>
               </a:solidFill>
             </a:ln>
           </p:spPr>
@@ -1452,17 +1727,19 @@
           </p:nvSpPr>
           <p:spPr>
             <a:xfrm>
-              <a:off x="3467100" y="3400425"/>
-              <a:ext cx="171450" cy="171450"/>
+              <a:off x="3448050" y="3429000"/>
+              <a:ext cx="381000" cy="381000"/>
             </a:xfrm>
             <a:prstGeom prst="ellipse">
               <a:avLst/>
             </a:prstGeom>
             <a:solidFill>
-              <a:srgbClr val="2445FF"/>
+              <a:srgbClr val="FFFFFF"/>
             </a:solidFill>
-            <a:ln>
-              <a:noFill/>
+            <a:ln w="66675">
+              <a:solidFill>
+                <a:srgbClr val="121316"/>
+              </a:solidFill>
             </a:ln>
           </p:spPr>
         </p:sp>
@@ -1474,8 +1751,8 @@
           </p:nvSpPr>
           <p:spPr>
             <a:xfrm>
-              <a:off x="3456432" y="3841750"/>
-              <a:ext cx="1717548" cy="410718"/>
+              <a:off x="3454908" y="4013200"/>
+              <a:ext cx="1962912" cy="469392"/>
             </a:xfrm>
             <a:prstGeom prst="rect">
               <a:avLst/>
@@ -1493,7 +1770,7 @@
             <a:p>
               <a:pPr algn="l"/>
               <a:r>
-                <a:rPr lang="zh-TW" sz="2100" b="1" dirty="0">
+                <a:rPr lang="zh-TW" sz="2400" b="1" dirty="0">
                   <a:solidFill>
                     <a:srgbClr val="121316"/>
                   </a:solidFill>
@@ -1514,8 +1791,8 @@
           </p:nvSpPr>
           <p:spPr>
             <a:xfrm>
-              <a:off x="3459480" y="4286250"/>
-              <a:ext cx="1348740" cy="598170"/>
+              <a:off x="3458718" y="4470400"/>
+              <a:ext cx="1483614" cy="646557"/>
             </a:xfrm>
             <a:prstGeom prst="rect">
               <a:avLst/>
@@ -1533,11 +1810,11 @@
             <a:p>
               <a:pPr algn="l">
                 <a:lnSpc>
-                  <a:spcPts val="2400"/>
+                  <a:spcPts val="2550"/>
                 </a:lnSpc>
               </a:pPr>
               <a:r>
-                <a:rPr lang="zh-TW" sz="1500" dirty="0">
+                <a:rPr lang="zh-TW" sz="1650" dirty="0">
                   <a:solidFill>
                     <a:srgbClr val="6B6D73"/>
                   </a:solidFill>
@@ -1548,7 +1825,7 @@
                 <a:t>選擇多到，</a:t>
               </a:r>
               <a:br>
-                <a:rPr lang="zh-TW" sz="1500" dirty="0">
+                <a:rPr lang="zh-TW" sz="1650" dirty="0">
                   <a:solidFill>
                     <a:srgbClr val="6B6D73"/>
                   </a:solidFill>
@@ -1558,7 +1835,7 @@
                 </a:rPr>
               </a:br>
               <a:r>
-                <a:rPr lang="zh-TW" sz="1500" dirty="0">
+                <a:rPr lang="zh-TW" sz="1650" dirty="0">
                   <a:solidFill>
                     <a:srgbClr val="6B6D73"/>
                   </a:solidFill>
@@ -1580,10 +1857,10 @@
         </p:nvGrpSpPr>
         <p:grpSpPr>
           <a:xfrm>
-            <a:off x="6229350" y="2622550"/>
-            <a:ext cx="2514600" cy="2261870"/>
-            <a:chOff x="6229350" y="2622550"/>
-            <a:chExt cx="2514600" cy="2261870"/>
+            <a:off x="6229350" y="2641600"/>
+            <a:ext cx="2800350" cy="2475357"/>
+            <a:chOff x="6229350" y="2641600"/>
+            <a:chExt cx="2800350" cy="2475357"/>
           </a:xfrm>
         </p:grpSpPr>
         <p:sp>
@@ -1594,8 +1871,8 @@
           </p:nvSpPr>
           <p:spPr>
             <a:xfrm>
-              <a:off x="6229350" y="2622550"/>
-              <a:ext cx="1484290" cy="819150"/>
+              <a:off x="6229350" y="2641600"/>
+              <a:ext cx="1690889" cy="933450"/>
             </a:xfrm>
             <a:prstGeom prst="rect">
               <a:avLst/>
@@ -1613,7 +1890,7 @@
             <a:p>
               <a:pPr algn="l"/>
               <a:r>
-                <a:rPr lang="zh-TW" sz="4200" b="1" dirty="0">
+                <a:rPr lang="zh-TW" sz="4800" b="1" dirty="0">
                   <a:solidFill>
                     <a:srgbClr val="121316"/>
                   </a:solidFill>
@@ -1634,8 +1911,8 @@
           </p:nvSpPr>
           <p:spPr>
             <a:xfrm>
-              <a:off x="6248400" y="3486150"/>
-              <a:ext cx="2495550" cy="9525"/>
+              <a:off x="6419850" y="3619500"/>
+              <a:ext cx="2609850" cy="9525"/>
             </a:xfrm>
             <a:custGeom>
               <a:avLst/>
@@ -1644,20 +1921,20 @@
               <a:cxnLst/>
               <a:rect l="l" t="t" r="r" b="b"/>
               <a:pathLst>
-                <a:path w="2495550" h="9525">
+                <a:path w="2609850" h="9525">
                   <a:moveTo>
                     <a:pt x="0" y="0"/>
                   </a:moveTo>
                   <a:lnTo>
-                    <a:pt x="2495550" y="0"/>
+                    <a:pt x="2609850" y="0"/>
                   </a:lnTo>
                 </a:path>
               </a:pathLst>
             </a:custGeom>
             <a:noFill/>
-            <a:ln w="19050">
+            <a:ln w="114300">
               <a:solidFill>
-                <a:srgbClr val="121316"/>
+                <a:srgbClr val="009645"/>
               </a:solidFill>
             </a:ln>
           </p:spPr>
@@ -1670,17 +1947,19 @@
           </p:nvSpPr>
           <p:spPr>
             <a:xfrm>
-              <a:off x="6248400" y="3400425"/>
-              <a:ext cx="171450" cy="171450"/>
+              <a:off x="6267450" y="3467100"/>
+              <a:ext cx="304800" cy="304800"/>
             </a:xfrm>
             <a:prstGeom prst="ellipse">
               <a:avLst/>
             </a:prstGeom>
             <a:solidFill>
-              <a:srgbClr val="121316"/>
+              <a:srgbClr val="FFFFFF"/>
             </a:solidFill>
-            <a:ln>
-              <a:noFill/>
+            <a:ln w="57150">
+              <a:solidFill>
+                <a:srgbClr val="009645"/>
+              </a:solidFill>
             </a:ln>
           </p:spPr>
         </p:sp>
@@ -1692,8 +1971,8 @@
           </p:nvSpPr>
           <p:spPr>
             <a:xfrm>
-              <a:off x="6237732" y="3841750"/>
-              <a:ext cx="1152144" cy="410718"/>
+              <a:off x="6236208" y="4013200"/>
+              <a:ext cx="1316736" cy="469392"/>
             </a:xfrm>
             <a:prstGeom prst="rect">
               <a:avLst/>
@@ -1711,7 +1990,7 @@
             <a:p>
               <a:pPr algn="l"/>
               <a:r>
-                <a:rPr lang="zh-TW" sz="2100" b="1" dirty="0">
+                <a:rPr lang="zh-TW" sz="2400" b="1" dirty="0">
                   <a:solidFill>
                     <a:srgbClr val="121316"/>
                   </a:solidFill>
@@ -1732,8 +2011,8 @@
           </p:nvSpPr>
           <p:spPr>
             <a:xfrm>
-              <a:off x="6240780" y="4286250"/>
-              <a:ext cx="1348740" cy="598170"/>
+              <a:off x="6240018" y="4470400"/>
+              <a:ext cx="1483614" cy="646557"/>
             </a:xfrm>
             <a:prstGeom prst="rect">
               <a:avLst/>
@@ -1751,11 +2030,11 @@
             <a:p>
               <a:pPr algn="l">
                 <a:lnSpc>
-                  <a:spcPts val="2400"/>
+                  <a:spcPts val="2550"/>
                 </a:lnSpc>
               </a:pPr>
               <a:r>
-                <a:rPr lang="zh-TW" sz="1500" dirty="0">
+                <a:rPr lang="zh-TW" sz="1650" dirty="0">
                   <a:solidFill>
                     <a:srgbClr val="6B6D73"/>
                   </a:solidFill>
@@ -1766,7 +2045,7 @@
                 <a:t>跟隊友對進度，</a:t>
               </a:r>
               <a:br>
-                <a:rPr lang="zh-TW" sz="1500" dirty="0">
+                <a:rPr lang="zh-TW" sz="1650" dirty="0">
                   <a:solidFill>
                     <a:srgbClr val="6B6D73"/>
                   </a:solidFill>
@@ -1776,7 +2055,7 @@
                 </a:rPr>
               </a:br>
               <a:r>
-                <a:rPr lang="zh-TW" sz="1500" dirty="0">
+                <a:rPr lang="zh-TW" sz="1650" dirty="0">
                   <a:solidFill>
                     <a:srgbClr val="6B6D73"/>
                   </a:solidFill>
@@ -1798,10 +2077,10 @@
         </p:nvGrpSpPr>
         <p:grpSpPr>
           <a:xfrm>
-            <a:off x="9010650" y="2622550"/>
-            <a:ext cx="2514600" cy="2261870"/>
-            <a:chOff x="9010650" y="2622550"/>
-            <a:chExt cx="2514600" cy="2261870"/>
+            <a:off x="9010650" y="2641600"/>
+            <a:ext cx="2324100" cy="2475357"/>
+            <a:chOff x="9010650" y="2641600"/>
+            <a:chExt cx="2324100" cy="2475357"/>
           </a:xfrm>
         </p:grpSpPr>
         <p:sp>
@@ -1812,8 +2091,8 @@
           </p:nvSpPr>
           <p:spPr>
             <a:xfrm>
-              <a:off x="9010650" y="2622550"/>
-              <a:ext cx="1484290" cy="819150"/>
+              <a:off x="9010650" y="2641600"/>
+              <a:ext cx="1690889" cy="933450"/>
             </a:xfrm>
             <a:prstGeom prst="rect">
               <a:avLst/>
@@ -1831,7 +2110,7 @@
             <a:p>
               <a:pPr algn="l"/>
               <a:r>
-                <a:rPr lang="zh-TW" sz="4200" b="1" dirty="0">
+                <a:rPr lang="zh-TW" sz="4800" b="1" dirty="0">
                   <a:solidFill>
                     <a:srgbClr val="121316"/>
                   </a:solidFill>
@@ -1852,8 +2131,8 @@
           </p:nvSpPr>
           <p:spPr>
             <a:xfrm>
-              <a:off x="9029700" y="3486150"/>
-              <a:ext cx="2495550" cy="9525"/>
+              <a:off x="9201150" y="3619500"/>
+              <a:ext cx="2133600" cy="9525"/>
             </a:xfrm>
             <a:custGeom>
               <a:avLst/>
@@ -1862,20 +2141,20 @@
               <a:cxnLst/>
               <a:rect l="l" t="t" r="r" b="b"/>
               <a:pathLst>
-                <a:path w="2495550" h="9525">
+                <a:path w="2133600" h="9525">
                   <a:moveTo>
                     <a:pt x="0" y="0"/>
                   </a:moveTo>
                   <a:lnTo>
-                    <a:pt x="2495550" y="0"/>
+                    <a:pt x="2133600" y="0"/>
                   </a:lnTo>
                 </a:path>
               </a:pathLst>
             </a:custGeom>
             <a:noFill/>
-            <a:ln w="19050">
+            <a:ln w="114300" cap="rnd">
               <a:solidFill>
-                <a:srgbClr val="121316"/>
+                <a:srgbClr val="009645"/>
               </a:solidFill>
             </a:ln>
           </p:spPr>
@@ -1888,17 +2167,19 @@
           </p:nvSpPr>
           <p:spPr>
             <a:xfrm>
-              <a:off x="9029700" y="3400425"/>
-              <a:ext cx="171450" cy="171450"/>
+              <a:off x="9048750" y="3467100"/>
+              <a:ext cx="304800" cy="304800"/>
             </a:xfrm>
             <a:prstGeom prst="ellipse">
               <a:avLst/>
             </a:prstGeom>
             <a:solidFill>
-              <a:srgbClr val="121316"/>
+              <a:srgbClr val="FFFFFF"/>
             </a:solidFill>
-            <a:ln>
-              <a:noFill/>
+            <a:ln w="57150">
+              <a:solidFill>
+                <a:srgbClr val="009645"/>
+              </a:solidFill>
             </a:ln>
           </p:spPr>
         </p:sp>
@@ -1910,8 +2191,8 @@
           </p:nvSpPr>
           <p:spPr>
             <a:xfrm>
-              <a:off x="9019032" y="3841750"/>
-              <a:ext cx="869442" cy="410718"/>
+              <a:off x="9017508" y="4013200"/>
+              <a:ext cx="993648" cy="469392"/>
             </a:xfrm>
             <a:prstGeom prst="rect">
               <a:avLst/>
@@ -1929,7 +2210,7 @@
             <a:p>
               <a:pPr algn="l"/>
               <a:r>
-                <a:rPr lang="zh-TW" sz="2100" b="1" dirty="0">
+                <a:rPr lang="zh-TW" sz="2400" b="1" dirty="0">
                   <a:solidFill>
                     <a:srgbClr val="121316"/>
                   </a:solidFill>
@@ -1950,8 +2231,8 @@
           </p:nvSpPr>
           <p:spPr>
             <a:xfrm>
-              <a:off x="9022080" y="4286250"/>
-              <a:ext cx="1348740" cy="598170"/>
+              <a:off x="9021318" y="4470400"/>
+              <a:ext cx="1483614" cy="646557"/>
             </a:xfrm>
             <a:prstGeom prst="rect">
               <a:avLst/>
@@ -1969,11 +2250,11 @@
             <a:p>
               <a:pPr algn="l">
                 <a:lnSpc>
-                  <a:spcPts val="2400"/>
+                  <a:spcPts val="2550"/>
                 </a:lnSpc>
               </a:pPr>
               <a:r>
-                <a:rPr lang="zh-TW" sz="1500" dirty="0">
+                <a:rPr lang="zh-TW" sz="1650" dirty="0">
                   <a:solidFill>
                     <a:srgbClr val="6B6D73"/>
                   </a:solidFill>
@@ -1984,7 +2265,7 @@
                 <a:t>趕作業與讀書，</a:t>
               </a:r>
               <a:br>
-                <a:rPr lang="zh-TW" sz="1500" dirty="0">
+                <a:rPr lang="zh-TW" sz="1650" dirty="0">
                   <a:solidFill>
                     <a:srgbClr val="6B6D73"/>
                   </a:solidFill>
@@ -1994,7 +2275,7 @@
                 </a:rPr>
               </a:br>
               <a:r>
-                <a:rPr lang="zh-TW" sz="1500" dirty="0">
+                <a:rPr lang="zh-TW" sz="1650" dirty="0">
                   <a:solidFill>
                     <a:srgbClr val="6B6D73"/>
                   </a:solidFill>
@@ -2010,62 +2291,7 @@
       </p:grpSp>
       <p:grpSp>
         <p:nvGrpSpPr>
-          <p:cNvPr id="30" name="note"/>
-          <p:cNvGrpSpPr/>
-          <p:nvPr/>
-        </p:nvGrpSpPr>
-        <p:grpSpPr>
-          <a:xfrm>
-            <a:off x="678942" y="5740400"/>
-            <a:ext cx="3984669" cy="264033"/>
-            <a:chOff x="678942" y="5740400"/>
-            <a:chExt cx="3984669" cy="264033"/>
-          </a:xfrm>
-        </p:grpSpPr>
-        <p:sp>
-          <p:nvSpPr>
-            <p:cNvPr id="29" name="TextBox 29"/>
-            <p:cNvSpPr txBox="1"/>
-            <p:nvPr/>
-          </p:nvSpPr>
-          <p:spPr>
-            <a:xfrm>
-              <a:off x="678942" y="5740400"/>
-              <a:ext cx="3984669" cy="264033"/>
-            </a:xfrm>
-            <a:prstGeom prst="rect">
-              <a:avLst/>
-            </a:prstGeom>
-            <a:noFill/>
-            <a:ln>
-              <a:noFill/>
-            </a:ln>
-          </p:spPr>
-          <p:txBody>
-            <a:bodyPr wrap="none" lIns="0" tIns="0" rIns="0" bIns="0" anchor="t" anchorCtr="0">
-              <a:spAutoFit/>
-            </a:bodyPr>
-            <a:lstStyle/>
-            <a:p>
-              <a:pPr algn="l"/>
-              <a:r>
-                <a:rPr lang="zh-TW" sz="1350" dirty="0">
-                  <a:solidFill>
-                    <a:srgbClr val="6B6D73"/>
-                  </a:solidFill>
-                  <a:latin typeface="+mn-lt"/>
-                  <a:ea typeface="+mn-ea"/>
-                  <a:cs typeface="+mn-cs"/>
-                </a:rPr>
-                <a:t>※ 時間與內容為示意，正式版會換成真實的一天。</a:t>
-              </a:r>
-            </a:p>
-          </p:txBody>
-        </p:sp>
-      </p:grpSp>
-      <p:grpSp>
-        <p:nvGrpSpPr>
-          <p:cNvPr id="33" name="footer"/>
+          <p:cNvPr id="31" name="footer"/>
           <p:cNvGrpSpPr/>
           <p:nvPr/>
         </p:nvGrpSpPr>
@@ -2079,14 +2305,14 @@
         </p:grpSpPr>
         <p:sp>
           <p:nvSpPr>
-            <p:cNvPr id="31" name="TextBox 31"/>
+            <p:cNvPr id="29" name="TextBox 29"/>
             <p:cNvSpPr txBox="1"/>
             <p:nvPr/>
           </p:nvSpPr>
           <p:spPr>
             <a:xfrm>
               <a:off x="679704" y="6324600"/>
-              <a:ext cx="1143000" cy="234696"/>
+              <a:ext cx="2734208" cy="234696"/>
             </a:xfrm>
             <a:prstGeom prst="rect">
               <a:avLst/>
@@ -2112,14 +2338,14 @@
                   <a:ea typeface="+mn-ea"/>
                   <a:cs typeface="+mn-cs"/>
                 </a:rPr>
-                <a:t>新加坡留學日常</a:t>
+                <a:t>新加坡留學日常　※ 時間與內容為示意</a:t>
               </a:r>
             </a:p>
           </p:txBody>
         </p:sp>
         <p:sp>
           <p:nvSpPr>
-            <p:cNvPr id="32" name="TextBox 32"/>
+            <p:cNvPr id="30" name="TextBox 30"/>
             <p:cNvSpPr txBox="1"/>
             <p:nvPr/>
           </p:nvSpPr>
@@ -3477,7 +3703,7 @@
           <p:spPr>
             <a:xfrm>
               <a:off x="678942" y="596900"/>
-              <a:ext cx="1304049" cy="264033"/>
+              <a:ext cx="940575" cy="264033"/>
             </a:xfrm>
             <a:prstGeom prst="rect">
               <a:avLst/>
@@ -3503,7 +3729,7 @@
                   <a:ea typeface="+mn-ea"/>
                   <a:cs typeface="+mn-cs"/>
                 </a:rPr>
-                <a:t>05　給後來的人</a:t>
+                <a:t>05　下一站</a:t>
               </a:r>
             </a:p>
           </p:txBody>
@@ -3557,10 +3783,10 @@
         </p:nvGrpSpPr>
         <p:grpSpPr>
           <a:xfrm>
-            <a:off x="666750" y="2038350"/>
-            <a:ext cx="10839450" cy="1060450"/>
-            <a:chOff x="666750" y="2038350"/>
-            <a:chExt cx="10839450" cy="1060450"/>
+            <a:off x="762000" y="2279650"/>
+            <a:ext cx="3340608" cy="863600"/>
+            <a:chOff x="762000" y="2279650"/>
+            <a:chExt cx="3340608" cy="863600"/>
           </a:xfrm>
         </p:grpSpPr>
         <p:sp>
@@ -3571,8 +3797,8 @@
           </p:nvSpPr>
           <p:spPr>
             <a:xfrm>
-              <a:off x="685800" y="2038350"/>
-              <a:ext cx="10820400" cy="9525"/>
+              <a:off x="914400" y="2495550"/>
+              <a:ext cx="9525" cy="647700"/>
             </a:xfrm>
             <a:custGeom>
               <a:avLst/>
@@ -3581,36 +3807,58 @@
               <a:cxnLst/>
               <a:rect l="l" t="t" r="r" b="b"/>
               <a:pathLst>
-                <a:path w="10820400" h="9525">
+                <a:path w="9525" h="647700">
                   <a:moveTo>
                     <a:pt x="0" y="0"/>
                   </a:moveTo>
                   <a:lnTo>
-                    <a:pt x="10820400" y="0"/>
+                    <a:pt x="0" y="647700"/>
                   </a:lnTo>
                 </a:path>
               </a:pathLst>
             </a:custGeom>
             <a:noFill/>
-            <a:ln w="9525">
+            <a:ln w="114300" cap="rnd">
               <a:solidFill>
-                <a:srgbClr val="121316">
-                  <a:alpha val="25000"/>
-                </a:srgbClr>
+                <a:srgbClr val="009645"/>
               </a:solidFill>
             </a:ln>
           </p:spPr>
         </p:sp>
         <p:sp>
           <p:nvSpPr>
-            <p:cNvPr id="6" name="TextBox 6"/>
+            <p:cNvPr id="6" name="Ellipse 6"/>
+            <p:cNvSpPr/>
+            <p:nvPr/>
+          </p:nvSpPr>
+          <p:spPr>
+            <a:xfrm>
+              <a:off x="762000" y="2343150"/>
+              <a:ext cx="304800" cy="304800"/>
+            </a:xfrm>
+            <a:prstGeom prst="ellipse">
+              <a:avLst/>
+            </a:prstGeom>
+            <a:solidFill>
+              <a:srgbClr val="FFFFFF"/>
+            </a:solidFill>
+            <a:ln w="57150">
+              <a:solidFill>
+                <a:srgbClr val="009645"/>
+              </a:solidFill>
+            </a:ln>
+          </p:spPr>
+        </p:sp>
+        <p:sp>
+          <p:nvSpPr>
+            <p:cNvPr id="7" name="TextBox 7"/>
             <p:cNvSpPr txBox="1"/>
             <p:nvPr/>
           </p:nvSpPr>
           <p:spPr>
             <a:xfrm>
-              <a:off x="666750" y="2165350"/>
-              <a:ext cx="756906" cy="933450"/>
+              <a:off x="1415034" y="2279650"/>
+              <a:ext cx="2571750" cy="528066"/>
             </a:xfrm>
             <a:prstGeom prst="rect">
               <a:avLst/>
@@ -3628,7 +3876,7 @@
             <a:p>
               <a:pPr algn="l"/>
               <a:r>
-                <a:rPr lang="zh-TW" sz="4800" b="1" dirty="0">
+                <a:rPr lang="zh-TW" sz="2700" b="1" dirty="0">
                   <a:solidFill>
                     <a:srgbClr val="121316"/>
                   </a:solidFill>
@@ -3636,21 +3884,21 @@
                   <a:ea typeface="+mn-ea"/>
                   <a:cs typeface="+mn-cs"/>
                 </a:rPr>
-                <a:t>01</a:t>
+                <a:t>冷氣外套隨身帶</a:t>
               </a:r>
             </a:p>
           </p:txBody>
         </p:sp>
         <p:sp>
           <p:nvSpPr>
-            <p:cNvPr id="7" name="TextBox 7"/>
+            <p:cNvPr id="8" name="TextBox 8"/>
             <p:cNvSpPr txBox="1"/>
             <p:nvPr/>
           </p:nvSpPr>
           <p:spPr>
             <a:xfrm>
-              <a:off x="2272284" y="2260600"/>
-              <a:ext cx="2571750" cy="528066"/>
+              <a:off x="1420368" y="2768600"/>
+              <a:ext cx="2682240" cy="322707"/>
             </a:xfrm>
             <a:prstGeom prst="rect">
               <a:avLst/>
@@ -3668,47 +3916,7 @@
             <a:p>
               <a:pPr algn="l"/>
               <a:r>
-                <a:rPr lang="zh-TW" sz="2700" b="1" dirty="0">
-                  <a:solidFill>
-                    <a:srgbClr val="121316"/>
-                  </a:solidFill>
-                  <a:latin typeface="+mn-lt"/>
-                  <a:ea typeface="+mn-ea"/>
-                  <a:cs typeface="+mn-cs"/>
-                </a:rPr>
-                <a:t>冷氣外套隨身帶</a:t>
-              </a:r>
-            </a:p>
-          </p:txBody>
-        </p:sp>
-        <p:sp>
-          <p:nvSpPr>
-            <p:cNvPr id="8" name="TextBox 8"/>
-            <p:cNvSpPr txBox="1"/>
-            <p:nvPr/>
-          </p:nvSpPr>
-          <p:spPr>
-            <a:xfrm>
-              <a:off x="2278380" y="2724150"/>
-              <a:ext cx="2438400" cy="293370"/>
-            </a:xfrm>
-            <a:prstGeom prst="rect">
-              <a:avLst/>
-            </a:prstGeom>
-            <a:noFill/>
-            <a:ln>
-              <a:noFill/>
-            </a:ln>
-          </p:spPr>
-          <p:txBody>
-            <a:bodyPr wrap="none" lIns="0" tIns="0" rIns="0" bIns="0" anchor="t" anchorCtr="0">
-              <a:spAutoFit/>
-            </a:bodyPr>
-            <a:lstStyle/>
-            <a:p>
-              <a:pPr algn="l"/>
-              <a:r>
-                <a:rPr lang="zh-TW" sz="1500" dirty="0">
+                <a:rPr lang="zh-TW" sz="1650" dirty="0">
                   <a:solidFill>
                     <a:srgbClr val="6B6D73"/>
                   </a:solidFill>
@@ -3730,10 +3938,10 @@
         </p:nvGrpSpPr>
         <p:grpSpPr>
           <a:xfrm>
-            <a:off x="666750" y="3181350"/>
-            <a:ext cx="10839450" cy="1060450"/>
-            <a:chOff x="666750" y="3181350"/>
-            <a:chExt cx="10839450" cy="1060450"/>
+            <a:off x="762000" y="3143250"/>
+            <a:ext cx="3588258" cy="1143000"/>
+            <a:chOff x="762000" y="3143250"/>
+            <a:chExt cx="3588258" cy="1143000"/>
           </a:xfrm>
         </p:grpSpPr>
         <p:sp>
@@ -3744,8 +3952,8 @@
           </p:nvSpPr>
           <p:spPr>
             <a:xfrm>
-              <a:off x="685800" y="3181350"/>
-              <a:ext cx="10820400" cy="9525"/>
+              <a:off x="914400" y="3143250"/>
+              <a:ext cx="9525" cy="1143000"/>
             </a:xfrm>
             <a:custGeom>
               <a:avLst/>
@@ -3754,36 +3962,58 @@
               <a:cxnLst/>
               <a:rect l="l" t="t" r="r" b="b"/>
               <a:pathLst>
-                <a:path w="10820400" h="9525">
+                <a:path w="9525" h="1143000">
                   <a:moveTo>
                     <a:pt x="0" y="0"/>
                   </a:moveTo>
                   <a:lnTo>
-                    <a:pt x="10820400" y="0"/>
+                    <a:pt x="0" y="1143000"/>
                   </a:lnTo>
                 </a:path>
               </a:pathLst>
             </a:custGeom>
             <a:noFill/>
-            <a:ln w="9525">
+            <a:ln w="114300" cap="rnd">
               <a:solidFill>
-                <a:srgbClr val="121316">
-                  <a:alpha val="25000"/>
-                </a:srgbClr>
+                <a:srgbClr val="009645"/>
               </a:solidFill>
             </a:ln>
           </p:spPr>
         </p:sp>
         <p:sp>
           <p:nvSpPr>
-            <p:cNvPr id="11" name="TextBox 11"/>
+            <p:cNvPr id="11" name="Ellipse 11"/>
+            <p:cNvSpPr/>
+            <p:nvPr/>
+          </p:nvSpPr>
+          <p:spPr>
+            <a:xfrm>
+              <a:off x="762000" y="3486150"/>
+              <a:ext cx="304800" cy="304800"/>
+            </a:xfrm>
+            <a:prstGeom prst="ellipse">
+              <a:avLst/>
+            </a:prstGeom>
+            <a:solidFill>
+              <a:srgbClr val="FFFFFF"/>
+            </a:solidFill>
+            <a:ln w="57150">
+              <a:solidFill>
+                <a:srgbClr val="009645"/>
+              </a:solidFill>
+            </a:ln>
+          </p:spPr>
+        </p:sp>
+        <p:sp>
+          <p:nvSpPr>
+            <p:cNvPr id="12" name="TextBox 12"/>
             <p:cNvSpPr txBox="1"/>
             <p:nvPr/>
           </p:nvSpPr>
           <p:spPr>
             <a:xfrm>
-              <a:off x="666750" y="3308350"/>
-              <a:ext cx="756906" cy="933450"/>
+              <a:off x="1415034" y="3422650"/>
+              <a:ext cx="2935224" cy="528066"/>
             </a:xfrm>
             <a:prstGeom prst="rect">
               <a:avLst/>
@@ -3801,7 +4031,7 @@
             <a:p>
               <a:pPr algn="l"/>
               <a:r>
-                <a:rPr lang="zh-TW" sz="4800" b="1" dirty="0">
+                <a:rPr lang="zh-TW" sz="2700" b="1" dirty="0">
                   <a:solidFill>
                     <a:srgbClr val="121316"/>
                   </a:solidFill>
@@ -3809,21 +4039,21 @@
                   <a:ea typeface="+mn-ea"/>
                   <a:cs typeface="+mn-cs"/>
                 </a:rPr>
-                <a:t>02</a:t>
+                <a:t>每週留一天給自己</a:t>
               </a:r>
             </a:p>
           </p:txBody>
         </p:sp>
         <p:sp>
           <p:nvSpPr>
-            <p:cNvPr id="12" name="TextBox 12"/>
+            <p:cNvPr id="13" name="TextBox 13"/>
             <p:cNvSpPr txBox="1"/>
             <p:nvPr/>
           </p:nvSpPr>
           <p:spPr>
             <a:xfrm>
-              <a:off x="2272284" y="3403600"/>
-              <a:ext cx="2935224" cy="528066"/>
+              <a:off x="1420368" y="3911600"/>
+              <a:ext cx="2460117" cy="322707"/>
             </a:xfrm>
             <a:prstGeom prst="rect">
               <a:avLst/>
@@ -3841,47 +4071,7 @@
             <a:p>
               <a:pPr algn="l"/>
               <a:r>
-                <a:rPr lang="zh-TW" sz="2700" b="1" dirty="0">
-                  <a:solidFill>
-                    <a:srgbClr val="121316"/>
-                  </a:solidFill>
-                  <a:latin typeface="+mn-lt"/>
-                  <a:ea typeface="+mn-ea"/>
-                  <a:cs typeface="+mn-cs"/>
-                </a:rPr>
-                <a:t>每週留一天給自己</a:t>
-              </a:r>
-            </a:p>
-          </p:txBody>
-        </p:sp>
-        <p:sp>
-          <p:nvSpPr>
-            <p:cNvPr id="13" name="TextBox 13"/>
-            <p:cNvSpPr txBox="1"/>
-            <p:nvPr/>
-          </p:nvSpPr>
-          <p:spPr>
-            <a:xfrm>
-              <a:off x="2278380" y="3867150"/>
-              <a:ext cx="2236470" cy="293370"/>
-            </a:xfrm>
-            <a:prstGeom prst="rect">
-              <a:avLst/>
-            </a:prstGeom>
-            <a:noFill/>
-            <a:ln>
-              <a:noFill/>
-            </a:ln>
-          </p:spPr>
-          <p:txBody>
-            <a:bodyPr wrap="none" lIns="0" tIns="0" rIns="0" bIns="0" anchor="t" anchorCtr="0">
-              <a:spAutoFit/>
-            </a:bodyPr>
-            <a:lstStyle/>
-            <a:p>
-              <a:pPr algn="l"/>
-              <a:r>
-                <a:rPr lang="zh-TW" sz="1500" dirty="0">
+                <a:rPr lang="zh-TW" sz="1650" dirty="0">
                   <a:solidFill>
                     <a:srgbClr val="6B6D73"/>
                   </a:solidFill>
@@ -3903,10 +4093,10 @@
         </p:nvGrpSpPr>
         <p:grpSpPr>
           <a:xfrm>
-            <a:off x="666750" y="4324350"/>
-            <a:ext cx="10839450" cy="1060450"/>
-            <a:chOff x="666750" y="4324350"/>
-            <a:chExt cx="10839450" cy="1060450"/>
+            <a:off x="762000" y="4286250"/>
+            <a:ext cx="4678680" cy="1091057"/>
+            <a:chOff x="762000" y="4286250"/>
+            <a:chExt cx="4678680" cy="1091057"/>
           </a:xfrm>
         </p:grpSpPr>
         <p:sp>
@@ -3917,8 +4107,8 @@
           </p:nvSpPr>
           <p:spPr>
             <a:xfrm>
-              <a:off x="685800" y="4324350"/>
-              <a:ext cx="10820400" cy="9525"/>
+              <a:off x="914400" y="4286250"/>
+              <a:ext cx="9525" cy="495300"/>
             </a:xfrm>
             <a:custGeom>
               <a:avLst/>
@@ -3927,36 +4117,58 @@
               <a:cxnLst/>
               <a:rect l="l" t="t" r="r" b="b"/>
               <a:pathLst>
-                <a:path w="10820400" h="9525">
+                <a:path w="9525" h="495300">
                   <a:moveTo>
                     <a:pt x="0" y="0"/>
                   </a:moveTo>
                   <a:lnTo>
-                    <a:pt x="10820400" y="0"/>
+                    <a:pt x="0" y="495300"/>
                   </a:lnTo>
                 </a:path>
               </a:pathLst>
             </a:custGeom>
             <a:noFill/>
-            <a:ln w="9525">
+            <a:ln w="114300" cap="rnd">
               <a:solidFill>
-                <a:srgbClr val="121316">
-                  <a:alpha val="25000"/>
-                </a:srgbClr>
+                <a:srgbClr val="009645"/>
               </a:solidFill>
             </a:ln>
           </p:spPr>
         </p:sp>
         <p:sp>
           <p:nvSpPr>
-            <p:cNvPr id="16" name="TextBox 16"/>
+            <p:cNvPr id="16" name="Ellipse 16"/>
+            <p:cNvSpPr/>
+            <p:nvPr/>
+          </p:nvSpPr>
+          <p:spPr>
+            <a:xfrm>
+              <a:off x="762000" y="4629150"/>
+              <a:ext cx="304800" cy="304800"/>
+            </a:xfrm>
+            <a:prstGeom prst="ellipse">
+              <a:avLst/>
+            </a:prstGeom>
+            <a:solidFill>
+              <a:srgbClr val="FFFFFF"/>
+            </a:solidFill>
+            <a:ln w="57150">
+              <a:solidFill>
+                <a:srgbClr val="009645"/>
+              </a:solidFill>
+            </a:ln>
+          </p:spPr>
+        </p:sp>
+        <p:sp>
+          <p:nvSpPr>
+            <p:cNvPr id="17" name="TextBox 17"/>
             <p:cNvSpPr txBox="1"/>
             <p:nvPr/>
           </p:nvSpPr>
           <p:spPr>
             <a:xfrm>
-              <a:off x="666750" y="4451350"/>
-              <a:ext cx="756906" cy="933450"/>
+              <a:off x="1415034" y="4565650"/>
+              <a:ext cx="4025646" cy="528066"/>
             </a:xfrm>
             <a:prstGeom prst="rect">
               <a:avLst/>
@@ -3974,7 +4186,7 @@
             <a:p>
               <a:pPr algn="l"/>
               <a:r>
-                <a:rPr lang="zh-TW" sz="4800" b="1" dirty="0">
+                <a:rPr lang="zh-TW" sz="2700" b="1" dirty="0">
                   <a:solidFill>
                     <a:srgbClr val="121316"/>
                   </a:solidFill>
@@ -3982,21 +4194,21 @@
                   <a:ea typeface="+mn-ea"/>
                   <a:cs typeface="+mn-cs"/>
                 </a:rPr>
-                <a:t>03</a:t>
+                <a:t>多跟不同國家的同學吃飯</a:t>
               </a:r>
             </a:p>
           </p:txBody>
         </p:sp>
         <p:sp>
           <p:nvSpPr>
-            <p:cNvPr id="17" name="TextBox 17"/>
+            <p:cNvPr id="18" name="TextBox 18"/>
             <p:cNvSpPr txBox="1"/>
             <p:nvPr/>
           </p:nvSpPr>
           <p:spPr>
             <a:xfrm>
-              <a:off x="2272284" y="4546600"/>
-              <a:ext cx="4025646" cy="528066"/>
+              <a:off x="1420368" y="5054600"/>
+              <a:ext cx="3126486" cy="322707"/>
             </a:xfrm>
             <a:prstGeom prst="rect">
               <a:avLst/>
@@ -4014,47 +4226,7 @@
             <a:p>
               <a:pPr algn="l"/>
               <a:r>
-                <a:rPr lang="zh-TW" sz="2700" b="1" dirty="0">
-                  <a:solidFill>
-                    <a:srgbClr val="121316"/>
-                  </a:solidFill>
-                  <a:latin typeface="+mn-lt"/>
-                  <a:ea typeface="+mn-ea"/>
-                  <a:cs typeface="+mn-cs"/>
-                </a:rPr>
-                <a:t>多跟不同國家的同學吃飯</a:t>
-              </a:r>
-            </a:p>
-          </p:txBody>
-        </p:sp>
-        <p:sp>
-          <p:nvSpPr>
-            <p:cNvPr id="18" name="TextBox 18"/>
-            <p:cNvSpPr txBox="1"/>
-            <p:nvPr/>
-          </p:nvSpPr>
-          <p:spPr>
-            <a:xfrm>
-              <a:off x="2278380" y="5010150"/>
-              <a:ext cx="2842260" cy="293370"/>
-            </a:xfrm>
-            <a:prstGeom prst="rect">
-              <a:avLst/>
-            </a:prstGeom>
-            <a:noFill/>
-            <a:ln>
-              <a:noFill/>
-            </a:ln>
-          </p:spPr>
-          <p:txBody>
-            <a:bodyPr wrap="none" lIns="0" tIns="0" rIns="0" bIns="0" anchor="t" anchorCtr="0">
-              <a:spAutoFit/>
-            </a:bodyPr>
-            <a:lstStyle/>
-            <a:p>
-              <a:pPr algn="l"/>
-              <a:r>
-                <a:rPr lang="zh-TW" sz="1500" dirty="0">
+                <a:rPr lang="zh-TW" sz="1650" dirty="0">
                   <a:solidFill>
                     <a:srgbClr val="6B6D73"/>
                   </a:solidFill>

</xml_diff>